<commit_message>
Deck: repo link on closing slide
</commit_message>
<xml_diff>
--- a/pitch/deck.pptx
+++ b/pitch/deck.pptx
@@ -5878,7 +5878,7 @@
                 </a:solidFill>
                 <a:latin typeface="Segoe UI"/>
               </a:rPr>
-              <a:t>[ github.com/&lt;user&gt;/kapora ]</a:t>
+              <a:t>github.com/89CF/kapora</a:t>
             </a:r>
           </a:p>
         </p:txBody>
@@ -6034,7 +6034,7 @@
                 </a:solidFill>
                 <a:latin typeface="Segoe UI"/>
               </a:rPr>
-              <a:t>[ https://&lt;demo-url&gt; ]  ·  devnet, Phantom</a:t>
+              <a:t>run locally on devnet, see README  ·  demo accounts built in</a:t>
             </a:r>
           </a:p>
         </p:txBody>

</xml_diff>

<commit_message>
Rename project to TwoKeys; English-only repo; refreshed screenshots, deck and demo video
</commit_message>
<xml_diff>
--- a/pitch/deck.pptx
+++ b/pitch/deck.pptx
@@ -511,7 +511,7 @@
           <a:lstStyle/>
           <a:p>
             <a:r>
-              <a:t>Hi, I'm [Name]. This is Kapora: trustless deposits for marketplaces, built as one trust component that any marketplace, in any sector, can plug in. Our one-liner: you can disappear, but not with my money.</a:t>
+              <a:t>Hi, I'm [Name]. This is TwoKeys: trustless deposits for marketplaces, built as one trust component that any marketplace, in any sector, can plug in. Our one-liner: you can disappear, but not with my money.</a:t>
             </a:r>
           </a:p>
         </p:txBody>
@@ -791,7 +791,7 @@
           <a:lstStyle/>
           <a:p>
             <a:r>
-              <a:t>Kapora is the law as code. The seller locks a stake first, so a fake seller has to risk their own money. The buyer locks the deposit into a vault owned by the program. Two confirmations at the handover release the money. If someone backs out or vanishes, the legal rule pays out automatically.</a:t>
+              <a:t>TwoKeys is the law as code. The seller locks a stake first, so a fake seller has to risk their own money. The buyer locks the deposit into a vault owned by the program. Two confirmations at the handover release the money. If someone backs out or vanishes, the legal rule pays out automatically.</a:t>
             </a:r>
           </a:p>
         </p:txBody>
@@ -1001,7 +1001,7 @@
           <a:lstStyle/>
           <a:p>
             <a:r>
-              <a:t>Integration is one script tag. A marketplace adds the widget to a listing page with a template, and the button opens the Kapora deal flow. Developers can use the TypeScript SDK instead, and every deal has a shareable link. Our two demo marketplaces, DemoAuto for cars and DemoRent for equipment rental, are fictional, and they run the same widget on the same program.</a:t>
+              <a:t>Integration is one script tag. A marketplace adds the widget to a listing page with a template, and the button opens the TwoKeys deal flow. Developers can use the TypeScript SDK instead, and every deal has a shareable link. Our two demo marketplaces, DemoAuto for cars and DemoRent for equipment rental, are fictional, and they run the same widget on the same program.</a:t>
             </a:r>
           </a:p>
         </p:txBody>
@@ -4238,13 +4238,13 @@
               </a:lnSpc>
             </a:pPr>
             <a:r>
-              <a:rPr sz="2400" b="1" i="0">
+              <a:rPr sz="2000" b="1" i="0">
                 <a:solidFill>
                   <a:srgbClr val="0A0F22"/>
                 </a:solidFill>
                 <a:latin typeface="Segoe UI"/>
               </a:rPr>
-              <a:t>K</a:t>
+              <a:t>2K</a:t>
             </a:r>
           </a:p>
         </p:txBody>
@@ -4283,7 +4283,7 @@
                 </a:solidFill>
                 <a:latin typeface="Segoe UI"/>
               </a:rPr>
-              <a:t>KAPORA PROTOCOL</a:t>
+              <a:t>TWOKEYS PROTOCOL</a:t>
             </a:r>
           </a:p>
         </p:txBody>
@@ -4330,7 +4330,7 @@
                 </a:gradFill>
                 <a:latin typeface="Segoe UI"/>
               </a:rPr>
-              <a:t>Kapora</a:t>
+              <a:t>TwoKeys</a:t>
             </a:r>
           </a:p>
         </p:txBody>
@@ -5268,13 +5268,13 @@
               </a:lnSpc>
             </a:pPr>
             <a:r>
-              <a:rPr sz="2400" b="1" i="0">
+              <a:rPr sz="2000" b="1" i="0">
                 <a:solidFill>
                   <a:srgbClr val="0A0F22"/>
                 </a:solidFill>
                 <a:latin typeface="Segoe UI"/>
               </a:rPr>
-              <a:t>K</a:t>
+              <a:t>2K</a:t>
             </a:r>
           </a:p>
         </p:txBody>
@@ -5878,7 +5878,7 @@
                 </a:solidFill>
                 <a:latin typeface="Segoe UI"/>
               </a:rPr>
-              <a:t>github.com/89CF/kapora</a:t>
+              <a:t>github.com/89CF/twokeys</a:t>
             </a:r>
           </a:p>
         </p:txBody>
@@ -6740,7 +6740,7 @@
                 </a:solidFill>
                 <a:latin typeface="Segoe UI"/>
               </a:rPr>
-              <a:t>Kapora</a:t>
+              <a:t>TwoKeys</a:t>
             </a:r>
             <a:r>
               <a:rPr sz="1000" b="0" i="0">
@@ -7782,7 +7782,7 @@
                 </a:solidFill>
                 <a:latin typeface="Segoe UI"/>
               </a:rPr>
-              <a:t>Kapora</a:t>
+              <a:t>TwoKeys</a:t>
             </a:r>
             <a:r>
               <a:rPr sz="1000" b="0" i="0">
@@ -8844,7 +8844,7 @@
                 </a:solidFill>
                 <a:latin typeface="Segoe UI"/>
               </a:rPr>
-              <a:t>Kapora</a:t>
+              <a:t>TwoKeys</a:t>
             </a:r>
             <a:r>
               <a:rPr sz="1000" b="0" i="0">
@@ -9810,7 +9810,7 @@
                 </a:solidFill>
                 <a:latin typeface="Segoe UI"/>
               </a:rPr>
-              <a:t>Kapora</a:t>
+              <a:t>TwoKeys</a:t>
             </a:r>
             <a:r>
               <a:rPr sz="1000" b="0" i="0">
@@ -10329,7 +10329,7 @@
                 </a:solidFill>
                 <a:latin typeface="Consolas"/>
               </a:rPr>
-              <a:t>programs/kapora/src/settle.rs</a:t>
+              <a:t>programs/twokeys/src/settle.rs</a:t>
             </a:r>
           </a:p>
         </p:txBody>
@@ -11565,7 +11565,7 @@
                 </a:solidFill>
                 <a:latin typeface="Segoe UI"/>
               </a:rPr>
-              <a:t>Kapora</a:t>
+              <a:t>TwoKeys</a:t>
             </a:r>
             <a:r>
               <a:rPr sz="1000" b="0" i="0">
@@ -14072,7 +14072,7 @@
                 </a:solidFill>
                 <a:latin typeface="Segoe UI"/>
               </a:rPr>
-              <a:t>Kapora</a:t>
+              <a:t>TwoKeys</a:t>
             </a:r>
             <a:r>
               <a:rPr sz="1000" b="0" i="0">
@@ -15501,7 +15501,7 @@
                 </a:solidFill>
                 <a:latin typeface="Segoe UI"/>
               </a:rPr>
-              <a:t>Kapora</a:t>
+              <a:t>TwoKeys</a:t>
             </a:r>
             <a:r>
               <a:rPr sz="1000" b="0" i="0">
@@ -16750,7 +16750,7 @@
                 </a:solidFill>
                 <a:latin typeface="Segoe UI"/>
               </a:rPr>
-              <a:t>Kapora</a:t>
+              <a:t>TwoKeys</a:t>
             </a:r>
             <a:r>
               <a:rPr sz="1000" b="0" i="0">

</xml_diff>

<commit_message>
Deck: team name Farazi, video note on closing slide
Co-Authored-By: Claude Opus 5.5 <noreply@anthropic.com>
</commit_message>
<xml_diff>
--- a/pitch/deck.pptx
+++ b/pitch/deck.pptx
@@ -5956,7 +5956,7 @@
                 </a:solidFill>
                 <a:latin typeface="Segoe UI"/>
               </a:rPr>
-              <a:t>[ public video link, ≤ 3 min ]</a:t>
+              <a:t>linked in the HackTribe submission (2:32)</a:t>
             </a:r>
           </a:p>
         </p:txBody>
@@ -6190,7 +6190,7 @@
                 </a:solidFill>
                 <a:latin typeface="Segoe UI"/>
               </a:rPr>
-              <a:t>[Team name]  ·  [Name Surname]  ·  ahmetenes2004@hotmail.com</a:t>
+              <a:t>Farazi</a:t>
             </a:r>
           </a:p>
         </p:txBody>

</xml_diff>